<commit_message>
Add OpenSCAD camera bracket and update poster
</commit_message>
<xml_diff>
--- a/docs/submission/04_作品海报_A1竖版_GitHub二维码.pptx
+++ b/docs/submission/04_作品海报_A1竖版_GitHub二维码.pptx
@@ -2,13 +2,13 @@
 <file path=ppt/presentation.xml><?xml version="1.0" encoding="utf-8"?>
 <p:presentation xmlns:p="http://schemas.openxmlformats.org/presentationml/2006/main">
   <p:sldMasterIdLst>
-    <p:sldMasterId xmlns:r="http://schemas.openxmlformats.org/officeDocument/2006/relationships" id="2147483648" r:id="R5244c285378d4b47"/>
+    <p:sldMasterId xmlns:r="http://schemas.openxmlformats.org/officeDocument/2006/relationships" id="2147483648" r:id="R386feca148214f54"/>
   </p:sldMasterIdLst>
   <p:notesMasterIdLst>
-    <p:notesMasterId xmlns:r="http://schemas.openxmlformats.org/officeDocument/2006/relationships" r:id="Ree24bb7a8d2e468c"/>
+    <p:notesMasterId xmlns:r="http://schemas.openxmlformats.org/officeDocument/2006/relationships" r:id="R882fcabee4064e96"/>
   </p:notesMasterIdLst>
   <p:sldIdLst>
-    <p:sldId xmlns:r="http://schemas.openxmlformats.org/officeDocument/2006/relationships" id="256" r:id="Rf222bbea57a342c9"/>
+    <p:sldId xmlns:r="http://schemas.openxmlformats.org/officeDocument/2006/relationships" id="256" r:id="R7c97f464c58f4d98"/>
   </p:sldIdLst>
   <p:sldSz cx="21383625" cy="30279975"/>
   <p:notesSz cx="6858000" cy="9144000"/>
@@ -482,7 +482,12 @@
           </a:p>
           <a:p xmlns:a="http://schemas.openxmlformats.org/drawingml/2006/main">
             <a:r>
-              <a:t>5. FPGA 摄像头、HDMI 和 UART 图片回显目前仍待目标板整链路实测验收。</a:t>
+              <a:t>5. 机械结构源文件：mechanical/亚克力摄像头支架.scad，参数化模型用于 3 mm 亚克力 MIPI 摄像头支架。</a:t>
+            </a:r>
+          </a:p>
+          <a:p xmlns:a="http://schemas.openxmlformats.org/drawingml/2006/main">
+            <a:r>
+              <a:t>6. FPGA 摄像头、HDMI 和 UART 图片回显目前仍待目标板整链路实测验收。</a:t>
             </a:r>
           </a:p>
         </p:txBody>
@@ -550,7 +555,7 @@
   </p:cSld>
   <p:clrMap bg1="lt1" tx1="dk1" bg2="lt2" tx2="dk2" accent1="accent1" accent2="accent2" accent3="accent3" accent4="accent4" accent5="accent5" accent6="accent6" hlink="hlink" folHlink="folHlink"/>
   <p:sldLayoutIdLst>
-    <p:sldLayoutId xmlns:r="http://schemas.openxmlformats.org/officeDocument/2006/relationships" id="2147483649" r:id="R1e0ad75572fb4263"/>
+    <p:sldLayoutId xmlns:r="http://schemas.openxmlformats.org/officeDocument/2006/relationships" id="2147483649" r:id="Rd95ee3ac0cdb4830"/>
   </p:sldLayoutIdLst>
   <p:txStyles>
     <p:titleStyle>
@@ -1101,7 +1106,7 @@
           <p:cNvPr id="48" name="top-accent">
             <a:extLst xmlns:a="http://schemas.openxmlformats.org/drawingml/2006/main">
               <a:ext uri="{FF2B5EF4-FFF2-40B4-BE49-F238E27FC236}">
-                <a16:creationId xmlns:a16="http://schemas.microsoft.com/office/drawing/2014/main" id="{7FEC15C1-4891-4103-853E-7A34FA4216D9}"/>
+                <a16:creationId xmlns:a16="http://schemas.microsoft.com/office/drawing/2014/main" id="{EF99E8D7-092E-46F5-AB3F-E2D0D51004BB}"/>
               </a:ext>
             </a:extLst>
           </p:cNvPr>
@@ -1132,7 +1137,7 @@
           <p:cNvPr id="2" name="eyebrow">
             <a:extLst xmlns:a="http://schemas.openxmlformats.org/drawingml/2006/main">
               <a:ext uri="{FF2B5EF4-FFF2-40B4-BE49-F238E27FC236}">
-                <a16:creationId xmlns:a16="http://schemas.microsoft.com/office/drawing/2014/main" id="{3B6AB3E8-4168-4B2C-87A5-8177AB1611B8}"/>
+                <a16:creationId xmlns:a16="http://schemas.microsoft.com/office/drawing/2014/main" id="{037FA5CE-A988-49F3-B49B-775132A5DBC2}"/>
               </a:ext>
             </a:extLst>
           </p:cNvPr>
@@ -1194,7 +1199,7 @@
           <p:cNvPr id="3" name="title">
             <a:extLst xmlns:a="http://schemas.openxmlformats.org/drawingml/2006/main">
               <a:ext uri="{FF2B5EF4-FFF2-40B4-BE49-F238E27FC236}">
-                <a16:creationId xmlns:a16="http://schemas.microsoft.com/office/drawing/2014/main" id="{8E3F6A48-757C-4973-B267-9DE23A1E1F01}"/>
+                <a16:creationId xmlns:a16="http://schemas.microsoft.com/office/drawing/2014/main" id="{958E36D9-F682-4125-8A5A-E3C992B2CC7A}"/>
               </a:ext>
             </a:extLst>
           </p:cNvPr>
@@ -1283,7 +1288,7 @@
           <p:cNvPr id="4" name="subtitle">
             <a:extLst xmlns:a="http://schemas.openxmlformats.org/drawingml/2006/main">
               <a:ext uri="{FF2B5EF4-FFF2-40B4-BE49-F238E27FC236}">
-                <a16:creationId xmlns:a16="http://schemas.microsoft.com/office/drawing/2014/main" id="{91857B00-F693-4D79-B6BD-B4FAAEAC5EAD}"/>
+                <a16:creationId xmlns:a16="http://schemas.microsoft.com/office/drawing/2014/main" id="{39F254F1-BBE7-4BA4-852E-DFF7F3FB2D0F}"/>
               </a:ext>
             </a:extLst>
           </p:cNvPr>
@@ -1345,7 +1350,7 @@
           <p:cNvPr id="5" name="number-divider">
             <a:extLst xmlns:a="http://schemas.openxmlformats.org/drawingml/2006/main">
               <a:ext uri="{FF2B5EF4-FFF2-40B4-BE49-F238E27FC236}">
-                <a16:creationId xmlns:a16="http://schemas.microsoft.com/office/drawing/2014/main" id="{531E169B-6E65-437D-9900-59B774A52E5A}"/>
+                <a16:creationId xmlns:a16="http://schemas.microsoft.com/office/drawing/2014/main" id="{AC6879D4-A786-44A4-ACAB-301ECAC6630B}"/>
               </a:ext>
             </a:extLst>
           </p:cNvPr>
@@ -1376,7 +1381,7 @@
           <p:cNvPr id="6" name="mode-number">
             <a:extLst xmlns:a="http://schemas.openxmlformats.org/drawingml/2006/main">
               <a:ext uri="{FF2B5EF4-FFF2-40B4-BE49-F238E27FC236}">
-                <a16:creationId xmlns:a16="http://schemas.microsoft.com/office/drawing/2014/main" id="{61CE6615-8394-4F15-B207-3905F5544886}"/>
+                <a16:creationId xmlns:a16="http://schemas.microsoft.com/office/drawing/2014/main" id="{B3BABA99-4A36-47E4-86E9-3D6358C47F96}"/>
               </a:ext>
             </a:extLst>
           </p:cNvPr>
@@ -1438,7 +1443,7 @@
           <p:cNvPr id="7" name="mode-number-label">
             <a:extLst xmlns:a="http://schemas.openxmlformats.org/drawingml/2006/main">
               <a:ext uri="{FF2B5EF4-FFF2-40B4-BE49-F238E27FC236}">
-                <a16:creationId xmlns:a16="http://schemas.microsoft.com/office/drawing/2014/main" id="{D7830E72-FA48-431B-90A1-572CB0479AE4}"/>
+                <a16:creationId xmlns:a16="http://schemas.microsoft.com/office/drawing/2014/main" id="{3049FD08-338C-4B8A-95DF-EC1E8BFAF06A}"/>
               </a:ext>
             </a:extLst>
           </p:cNvPr>
@@ -1504,7 +1509,7 @@
           <p:nvPr/>
         </p:nvPicPr>
         <p:blipFill>
-          <a:blip xmlns:r="http://schemas.openxmlformats.org/officeDocument/2006/relationships" xmlns:a="http://schemas.openxmlformats.org/drawingml/2006/main" r:embed="R76eebb6a844c4ca0"/>
+          <a:blip xmlns:r="http://schemas.openxmlformats.org/officeDocument/2006/relationships" xmlns:a="http://schemas.openxmlformats.org/drawingml/2006/main" r:embed="Rb4a8f7d294014270"/>
           <a:srcRect xmlns:a="http://schemas.openxmlformats.org/drawingml/2006/main" l="24" t="0" r="24" b="0"/>
           <a:stretch xmlns:a="http://schemas.openxmlformats.org/drawingml/2006/main">
             <a:fillRect l="0" t="0" r="0" b="0"/>
@@ -1525,7 +1530,7 @@
           <p:cNvPr id="9" name="hero-caption">
             <a:extLst xmlns:a="http://schemas.openxmlformats.org/drawingml/2006/main">
               <a:ext uri="{FF2B5EF4-FFF2-40B4-BE49-F238E27FC236}">
-                <a16:creationId xmlns:a16="http://schemas.microsoft.com/office/drawing/2014/main" id="{DAF44BC8-A5D6-4E8D-99BE-1F2BC90AA286}"/>
+                <a16:creationId xmlns:a16="http://schemas.microsoft.com/office/drawing/2014/main" id="{763569A9-5524-4E64-96A3-FEACA360013E}"/>
               </a:ext>
             </a:extLst>
           </p:cNvPr>
@@ -1587,7 +1592,7 @@
           <p:cNvPr id="10" name="fpga-title">
             <a:extLst xmlns:a="http://schemas.openxmlformats.org/drawingml/2006/main">
               <a:ext uri="{FF2B5EF4-FFF2-40B4-BE49-F238E27FC236}">
-                <a16:creationId xmlns:a16="http://schemas.microsoft.com/office/drawing/2014/main" id="{F5D47975-8E71-4071-9EEB-C3CEC9AB99B9}"/>
+                <a16:creationId xmlns:a16="http://schemas.microsoft.com/office/drawing/2014/main" id="{0FA3AF68-D015-47E8-B5EF-F395CF442525}"/>
               </a:ext>
             </a:extLst>
           </p:cNvPr>
@@ -1649,7 +1654,7 @@
           <p:cNvPr id="11" name="fpga-rule">
             <a:extLst xmlns:a="http://schemas.openxmlformats.org/drawingml/2006/main">
               <a:ext uri="{FF2B5EF4-FFF2-40B4-BE49-F238E27FC236}">
-                <a16:creationId xmlns:a16="http://schemas.microsoft.com/office/drawing/2014/main" id="{D0B46F8D-4A54-4B8E-BAED-FC76096359D4}"/>
+                <a16:creationId xmlns:a16="http://schemas.microsoft.com/office/drawing/2014/main" id="{BD80FCE6-2CAB-45AD-8EB6-F1D4C8C9183F}"/>
               </a:ext>
             </a:extLst>
           </p:cNvPr>
@@ -1680,7 +1685,7 @@
           <p:cNvPr id="12" name="fpga-accent">
             <a:extLst xmlns:a="http://schemas.openxmlformats.org/drawingml/2006/main">
               <a:ext uri="{FF2B5EF4-FFF2-40B4-BE49-F238E27FC236}">
-                <a16:creationId xmlns:a16="http://schemas.microsoft.com/office/drawing/2014/main" id="{2297B6BE-52CD-4B73-B2B5-6D1543CBE70C}"/>
+                <a16:creationId xmlns:a16="http://schemas.microsoft.com/office/drawing/2014/main" id="{7B3C6D2B-689C-4F0A-8936-C46EA37ADDBD}"/>
               </a:ext>
             </a:extLst>
           </p:cNvPr>
@@ -1711,7 +1716,7 @@
           <p:cNvPr id="13" name="fpga-flow">
             <a:extLst xmlns:a="http://schemas.openxmlformats.org/drawingml/2006/main">
               <a:ext uri="{FF2B5EF4-FFF2-40B4-BE49-F238E27FC236}">
-                <a16:creationId xmlns:a16="http://schemas.microsoft.com/office/drawing/2014/main" id="{C05B127B-4D3C-40E8-8DF1-5F52588F0654}"/>
+                <a16:creationId xmlns:a16="http://schemas.microsoft.com/office/drawing/2014/main" id="{BC10B167-52D2-4FE7-967E-1BA09679F4DE}"/>
               </a:ext>
             </a:extLst>
           </p:cNvPr>
@@ -1773,7 +1778,7 @@
           <p:cNvPr id="14" name="fpga-modes">
             <a:extLst xmlns:a="http://schemas.openxmlformats.org/drawingml/2006/main">
               <a:ext uri="{FF2B5EF4-FFF2-40B4-BE49-F238E27FC236}">
-                <a16:creationId xmlns:a16="http://schemas.microsoft.com/office/drawing/2014/main" id="{8BC4813F-1B20-4FE3-AF42-FEB620627793}"/>
+                <a16:creationId xmlns:a16="http://schemas.microsoft.com/office/drawing/2014/main" id="{DECC68B1-1612-4A27-81F8-D7B610D50099}"/>
               </a:ext>
             </a:extLst>
           </p:cNvPr>
@@ -1835,7 +1840,7 @@
           <p:cNvPr id="15" name="fpga-detail">
             <a:extLst xmlns:a="http://schemas.openxmlformats.org/drawingml/2006/main">
               <a:ext uri="{FF2B5EF4-FFF2-40B4-BE49-F238E27FC236}">
-                <a16:creationId xmlns:a16="http://schemas.microsoft.com/office/drawing/2014/main" id="{1B43AA65-9088-427C-B2CC-6B461F14B79F}"/>
+                <a16:creationId xmlns:a16="http://schemas.microsoft.com/office/drawing/2014/main" id="{B05ECC70-B753-4529-B750-B2A6F39A8EE2}"/>
               </a:ext>
             </a:extLst>
           </p:cNvPr>
@@ -1924,7 +1929,7 @@
           <p:cNvPr id="16" name="pc-title">
             <a:extLst xmlns:a="http://schemas.openxmlformats.org/drawingml/2006/main">
               <a:ext uri="{FF2B5EF4-FFF2-40B4-BE49-F238E27FC236}">
-                <a16:creationId xmlns:a16="http://schemas.microsoft.com/office/drawing/2014/main" id="{AEEE25BE-1429-48BB-BE9F-300275BB7096}"/>
+                <a16:creationId xmlns:a16="http://schemas.microsoft.com/office/drawing/2014/main" id="{1D695B41-25E9-4672-B95E-21B4A70758D7}"/>
               </a:ext>
             </a:extLst>
           </p:cNvPr>
@@ -1986,7 +1991,7 @@
           <p:cNvPr id="17" name="pc-rule">
             <a:extLst xmlns:a="http://schemas.openxmlformats.org/drawingml/2006/main">
               <a:ext uri="{FF2B5EF4-FFF2-40B4-BE49-F238E27FC236}">
-                <a16:creationId xmlns:a16="http://schemas.microsoft.com/office/drawing/2014/main" id="{C1D32E43-DE76-4653-A017-F135987D0488}"/>
+                <a16:creationId xmlns:a16="http://schemas.microsoft.com/office/drawing/2014/main" id="{80360FEF-D4C7-46AB-98F8-5722D4296F8D}"/>
               </a:ext>
             </a:extLst>
           </p:cNvPr>
@@ -2017,7 +2022,7 @@
           <p:cNvPr id="18" name="pc-accent">
             <a:extLst xmlns:a="http://schemas.openxmlformats.org/drawingml/2006/main">
               <a:ext uri="{FF2B5EF4-FFF2-40B4-BE49-F238E27FC236}">
-                <a16:creationId xmlns:a16="http://schemas.microsoft.com/office/drawing/2014/main" id="{DF8E14B5-AAE8-46C0-8591-28A6F6FCC109}"/>
+                <a16:creationId xmlns:a16="http://schemas.microsoft.com/office/drawing/2014/main" id="{3AC05B68-9D66-48A7-94FA-261EDE985EEA}"/>
               </a:ext>
             </a:extLst>
           </p:cNvPr>
@@ -2048,7 +2053,7 @@
           <p:cNvPr id="19" name="pc-flow">
             <a:extLst xmlns:a="http://schemas.openxmlformats.org/drawingml/2006/main">
               <a:ext uri="{FF2B5EF4-FFF2-40B4-BE49-F238E27FC236}">
-                <a16:creationId xmlns:a16="http://schemas.microsoft.com/office/drawing/2014/main" id="{8A6627BD-28B0-4DBF-9135-5F2C671840A8}"/>
+                <a16:creationId xmlns:a16="http://schemas.microsoft.com/office/drawing/2014/main" id="{23065558-F821-4AC5-8B94-B300A764615B}"/>
               </a:ext>
             </a:extLst>
           </p:cNvPr>
@@ -2114,7 +2119,7 @@
           <p:nvPr/>
         </p:nvPicPr>
         <p:blipFill>
-          <a:blip xmlns:r="http://schemas.openxmlformats.org/officeDocument/2006/relationships" xmlns:a="http://schemas.openxmlformats.org/drawingml/2006/main" r:embed="Rd51d6e4327324e92"/>
+          <a:blip xmlns:r="http://schemas.openxmlformats.org/officeDocument/2006/relationships" xmlns:a="http://schemas.openxmlformats.org/drawingml/2006/main" r:embed="R9fec1012d59f4684"/>
           <a:stretch xmlns:a="http://schemas.openxmlformats.org/drawingml/2006/main"/>
         </p:blipFill>
         <p:spPr>
@@ -2132,7 +2137,7 @@
           <p:cNvPr id="21" name="plate-image-outline">
             <a:extLst xmlns:a="http://schemas.openxmlformats.org/drawingml/2006/main">
               <a:ext uri="{FF2B5EF4-FFF2-40B4-BE49-F238E27FC236}">
-                <a16:creationId xmlns:a16="http://schemas.microsoft.com/office/drawing/2014/main" id="{9586C6D0-1825-4420-8160-31F7FD3D66DC}"/>
+                <a16:creationId xmlns:a16="http://schemas.microsoft.com/office/drawing/2014/main" id="{78A286C9-BB53-40AC-90D0-A95771364374}"/>
               </a:ext>
             </a:extLst>
           </p:cNvPr>
@@ -2163,7 +2168,7 @@
           <p:cNvPr id="22" name="plate-sample-label">
             <a:extLst xmlns:a="http://schemas.openxmlformats.org/drawingml/2006/main">
               <a:ext uri="{FF2B5EF4-FFF2-40B4-BE49-F238E27FC236}">
-                <a16:creationId xmlns:a16="http://schemas.microsoft.com/office/drawing/2014/main" id="{A5CFAB61-C0E3-4DFA-8C85-7AEEFC0A0C1C}"/>
+                <a16:creationId xmlns:a16="http://schemas.microsoft.com/office/drawing/2014/main" id="{03240DFB-3E0D-4066-B5B6-DBE74447EDEF}"/>
               </a:ext>
             </a:extLst>
           </p:cNvPr>
@@ -2225,7 +2230,7 @@
           <p:cNvPr id="23" name="plate-result">
             <a:extLst xmlns:a="http://schemas.openxmlformats.org/drawingml/2006/main">
               <a:ext uri="{FF2B5EF4-FFF2-40B4-BE49-F238E27FC236}">
-                <a16:creationId xmlns:a16="http://schemas.microsoft.com/office/drawing/2014/main" id="{0A4C7014-D24D-4744-B482-3A8C5BB06563}"/>
+                <a16:creationId xmlns:a16="http://schemas.microsoft.com/office/drawing/2014/main" id="{87CC8EAD-CA39-4660-A685-06416D594829}"/>
               </a:ext>
             </a:extLst>
           </p:cNvPr>
@@ -2287,7 +2292,7 @@
           <p:cNvPr id="24" name="plate-result-detail">
             <a:extLst xmlns:a="http://schemas.openxmlformats.org/drawingml/2006/main">
               <a:ext uri="{FF2B5EF4-FFF2-40B4-BE49-F238E27FC236}">
-                <a16:creationId xmlns:a16="http://schemas.microsoft.com/office/drawing/2014/main" id="{8C801E24-B18F-471E-A101-506C5C7EABDF}"/>
+                <a16:creationId xmlns:a16="http://schemas.microsoft.com/office/drawing/2014/main" id="{21876209-A4F4-49FF-8BF1-299A34638D1A}"/>
               </a:ext>
             </a:extLst>
           </p:cNvPr>
@@ -2376,7 +2381,7 @@
           <p:cNvPr id="25" name="transfer-limit">
             <a:extLst xmlns:a="http://schemas.openxmlformats.org/drawingml/2006/main">
               <a:ext uri="{FF2B5EF4-FFF2-40B4-BE49-F238E27FC236}">
-                <a16:creationId xmlns:a16="http://schemas.microsoft.com/office/drawing/2014/main" id="{27065BC5-943E-43DB-93B6-92429CEFF3C5}"/>
+                <a16:creationId xmlns:a16="http://schemas.microsoft.com/office/drawing/2014/main" id="{C4F8AC7E-421E-42CF-B368-48282A3660CD}"/>
               </a:ext>
             </a:extLst>
           </p:cNvPr>
@@ -2438,7 +2443,7 @@
           <p:cNvPr id="26" name="metrics-rule">
             <a:extLst xmlns:a="http://schemas.openxmlformats.org/drawingml/2006/main">
               <a:ext uri="{FF2B5EF4-FFF2-40B4-BE49-F238E27FC236}">
-                <a16:creationId xmlns:a16="http://schemas.microsoft.com/office/drawing/2014/main" id="{B93495E2-A421-4F23-8470-87F4E8DA4217}"/>
+                <a16:creationId xmlns:a16="http://schemas.microsoft.com/office/drawing/2014/main" id="{91524238-5F4D-49A0-B1C6-541F8081284A}"/>
               </a:ext>
             </a:extLst>
           </p:cNvPr>
@@ -2469,7 +2474,7 @@
           <p:cNvPr id="27" name="metrics-accent">
             <a:extLst xmlns:a="http://schemas.openxmlformats.org/drawingml/2006/main">
               <a:ext uri="{FF2B5EF4-FFF2-40B4-BE49-F238E27FC236}">
-                <a16:creationId xmlns:a16="http://schemas.microsoft.com/office/drawing/2014/main" id="{14C63EEE-F1E9-4895-90B3-9E964DB7E246}"/>
+                <a16:creationId xmlns:a16="http://schemas.microsoft.com/office/drawing/2014/main" id="{F987958B-1810-45B1-99CB-C93787911014}"/>
               </a:ext>
             </a:extLst>
           </p:cNvPr>
@@ -2500,7 +2505,7 @@
           <p:cNvPr id="28" name="metric-label-0">
             <a:extLst xmlns:a="http://schemas.openxmlformats.org/drawingml/2006/main">
               <a:ext uri="{FF2B5EF4-FFF2-40B4-BE49-F238E27FC236}">
-                <a16:creationId xmlns:a16="http://schemas.microsoft.com/office/drawing/2014/main" id="{C8148D86-7041-48BD-97EE-887466004F3D}"/>
+                <a16:creationId xmlns:a16="http://schemas.microsoft.com/office/drawing/2014/main" id="{458B707E-CB5F-459C-A7DD-A03029418619}"/>
               </a:ext>
             </a:extLst>
           </p:cNvPr>
@@ -2562,7 +2567,7 @@
           <p:cNvPr id="29" name="metric-value-0">
             <a:extLst xmlns:a="http://schemas.openxmlformats.org/drawingml/2006/main">
               <a:ext uri="{FF2B5EF4-FFF2-40B4-BE49-F238E27FC236}">
-                <a16:creationId xmlns:a16="http://schemas.microsoft.com/office/drawing/2014/main" id="{7BD3777C-246B-4CB1-BDD1-16073D86A3B7}"/>
+                <a16:creationId xmlns:a16="http://schemas.microsoft.com/office/drawing/2014/main" id="{1BE5FA6D-1F9C-49BC-8964-F31F815213F5}"/>
               </a:ext>
             </a:extLst>
           </p:cNvPr>
@@ -2624,7 +2629,7 @@
           <p:cNvPr id="30" name="metric-note-0">
             <a:extLst xmlns:a="http://schemas.openxmlformats.org/drawingml/2006/main">
               <a:ext uri="{FF2B5EF4-FFF2-40B4-BE49-F238E27FC236}">
-                <a16:creationId xmlns:a16="http://schemas.microsoft.com/office/drawing/2014/main" id="{9BC4EAD8-8C5C-483B-ABB7-90BF14449C7C}"/>
+                <a16:creationId xmlns:a16="http://schemas.microsoft.com/office/drawing/2014/main" id="{5AF1C7C7-874D-4E0F-B928-1BA52BED1F56}"/>
               </a:ext>
             </a:extLst>
           </p:cNvPr>
@@ -2686,7 +2691,7 @@
           <p:cNvPr id="31" name="metric-label-1">
             <a:extLst xmlns:a="http://schemas.openxmlformats.org/drawingml/2006/main">
               <a:ext uri="{FF2B5EF4-FFF2-40B4-BE49-F238E27FC236}">
-                <a16:creationId xmlns:a16="http://schemas.microsoft.com/office/drawing/2014/main" id="{9DA5562C-9FCF-4B9A-A75D-6231138BC459}"/>
+                <a16:creationId xmlns:a16="http://schemas.microsoft.com/office/drawing/2014/main" id="{918FE87D-CC65-4C3E-9BE8-8AEFD064BCA0}"/>
               </a:ext>
             </a:extLst>
           </p:cNvPr>
@@ -2748,7 +2753,7 @@
           <p:cNvPr id="32" name="metric-value-1">
             <a:extLst xmlns:a="http://schemas.openxmlformats.org/drawingml/2006/main">
               <a:ext uri="{FF2B5EF4-FFF2-40B4-BE49-F238E27FC236}">
-                <a16:creationId xmlns:a16="http://schemas.microsoft.com/office/drawing/2014/main" id="{C8C1B44E-1C2B-4D9A-99D8-B7BB6416D72C}"/>
+                <a16:creationId xmlns:a16="http://schemas.microsoft.com/office/drawing/2014/main" id="{7B080B23-A118-44DF-83FF-C402498736CC}"/>
               </a:ext>
             </a:extLst>
           </p:cNvPr>
@@ -2810,7 +2815,7 @@
           <p:cNvPr id="33" name="metric-note-1">
             <a:extLst xmlns:a="http://schemas.openxmlformats.org/drawingml/2006/main">
               <a:ext uri="{FF2B5EF4-FFF2-40B4-BE49-F238E27FC236}">
-                <a16:creationId xmlns:a16="http://schemas.microsoft.com/office/drawing/2014/main" id="{EC678102-AA06-4B49-A571-7448178D5313}"/>
+                <a16:creationId xmlns:a16="http://schemas.microsoft.com/office/drawing/2014/main" id="{4D71FA64-8FE3-4C62-A8B6-F8EEF01E6B8E}"/>
               </a:ext>
             </a:extLst>
           </p:cNvPr>
@@ -2872,7 +2877,7 @@
           <p:cNvPr id="34" name="metric-label-2">
             <a:extLst xmlns:a="http://schemas.openxmlformats.org/drawingml/2006/main">
               <a:ext uri="{FF2B5EF4-FFF2-40B4-BE49-F238E27FC236}">
-                <a16:creationId xmlns:a16="http://schemas.microsoft.com/office/drawing/2014/main" id="{3B8C7B8D-9E83-4442-8AB3-DFE88AD09991}"/>
+                <a16:creationId xmlns:a16="http://schemas.microsoft.com/office/drawing/2014/main" id="{BD6BA886-0480-46F2-A87F-FD421DC4F865}"/>
               </a:ext>
             </a:extLst>
           </p:cNvPr>
@@ -2934,7 +2939,7 @@
           <p:cNvPr id="35" name="metric-value-2">
             <a:extLst xmlns:a="http://schemas.openxmlformats.org/drawingml/2006/main">
               <a:ext uri="{FF2B5EF4-FFF2-40B4-BE49-F238E27FC236}">
-                <a16:creationId xmlns:a16="http://schemas.microsoft.com/office/drawing/2014/main" id="{4C27B7FA-D155-46B1-ADD3-B900A4F7EF4D}"/>
+                <a16:creationId xmlns:a16="http://schemas.microsoft.com/office/drawing/2014/main" id="{56124661-7805-4EA0-88EE-4200EDABA39A}"/>
               </a:ext>
             </a:extLst>
           </p:cNvPr>
@@ -2996,7 +3001,7 @@
           <p:cNvPr id="36" name="metric-note-2">
             <a:extLst xmlns:a="http://schemas.openxmlformats.org/drawingml/2006/main">
               <a:ext uri="{FF2B5EF4-FFF2-40B4-BE49-F238E27FC236}">
-                <a16:creationId xmlns:a16="http://schemas.microsoft.com/office/drawing/2014/main" id="{79093574-BD59-4B25-9ED8-1AE2FAB5E65B}"/>
+                <a16:creationId xmlns:a16="http://schemas.microsoft.com/office/drawing/2014/main" id="{874722BE-F00E-4513-958A-9B563B184B17}"/>
               </a:ext>
             </a:extLst>
           </p:cNvPr>
@@ -3058,7 +3063,7 @@
           <p:cNvPr id="37" name="metrics-divider-1">
             <a:extLst xmlns:a="http://schemas.openxmlformats.org/drawingml/2006/main">
               <a:ext uri="{FF2B5EF4-FFF2-40B4-BE49-F238E27FC236}">
-                <a16:creationId xmlns:a16="http://schemas.microsoft.com/office/drawing/2014/main" id="{1F98232E-C3AE-4A6C-8CB5-F03A29504300}"/>
+                <a16:creationId xmlns:a16="http://schemas.microsoft.com/office/drawing/2014/main" id="{D3EFDD01-C615-44F2-8DEA-011096D8C918}"/>
               </a:ext>
             </a:extLst>
           </p:cNvPr>
@@ -3089,7 +3094,7 @@
           <p:cNvPr id="38" name="metrics-divider-2">
             <a:extLst xmlns:a="http://schemas.openxmlformats.org/drawingml/2006/main">
               <a:ext uri="{FF2B5EF4-FFF2-40B4-BE49-F238E27FC236}">
-                <a16:creationId xmlns:a16="http://schemas.microsoft.com/office/drawing/2014/main" id="{6A461472-5586-4D99-A6C1-146FE0E18329}"/>
+                <a16:creationId xmlns:a16="http://schemas.microsoft.com/office/drawing/2014/main" id="{29A78B7E-A28D-4822-87F2-5987CAE54809}"/>
               </a:ext>
             </a:extLst>
           </p:cNvPr>
@@ -3120,7 +3125,7 @@
           <p:cNvPr id="39" name="acceptance-note-bg">
             <a:extLst xmlns:a="http://schemas.openxmlformats.org/drawingml/2006/main">
               <a:ext uri="{FF2B5EF4-FFF2-40B4-BE49-F238E27FC236}">
-                <a16:creationId xmlns:a16="http://schemas.microsoft.com/office/drawing/2014/main" id="{8B9814C7-1241-4583-B358-D70B417FF5B8}"/>
+                <a16:creationId xmlns:a16="http://schemas.microsoft.com/office/drawing/2014/main" id="{6DBEF190-78B6-4962-8C51-D0C2350BC6ED}"/>
               </a:ext>
             </a:extLst>
           </p:cNvPr>
@@ -3151,7 +3156,7 @@
           <p:cNvPr id="40" name="acceptance-note">
             <a:extLst xmlns:a="http://schemas.openxmlformats.org/drawingml/2006/main">
               <a:ext uri="{FF2B5EF4-FFF2-40B4-BE49-F238E27FC236}">
-                <a16:creationId xmlns:a16="http://schemas.microsoft.com/office/drawing/2014/main" id="{C82D136A-5DEB-4FC0-A358-49FCA67ED7D5}"/>
+                <a16:creationId xmlns:a16="http://schemas.microsoft.com/office/drawing/2014/main" id="{4F75D2C5-723B-4A48-91D7-411CCA51AAC7}"/>
               </a:ext>
             </a:extLst>
           </p:cNvPr>
@@ -3213,7 +3218,7 @@
           <p:cNvPr id="41" name="footer-rule">
             <a:extLst xmlns:a="http://schemas.openxmlformats.org/drawingml/2006/main">
               <a:ext uri="{FF2B5EF4-FFF2-40B4-BE49-F238E27FC236}">
-                <a16:creationId xmlns:a16="http://schemas.microsoft.com/office/drawing/2014/main" id="{F864B356-E056-4FA2-B2C2-08D5511BC89D}"/>
+                <a16:creationId xmlns:a16="http://schemas.microsoft.com/office/drawing/2014/main" id="{7C0C2F9F-115B-44C9-8089-5ED000C394E2}"/>
               </a:ext>
             </a:extLst>
           </p:cNvPr>
@@ -3244,7 +3249,7 @@
           <p:cNvPr id="42" name="qr-heading">
             <a:extLst xmlns:a="http://schemas.openxmlformats.org/drawingml/2006/main">
               <a:ext uri="{FF2B5EF4-FFF2-40B4-BE49-F238E27FC236}">
-                <a16:creationId xmlns:a16="http://schemas.microsoft.com/office/drawing/2014/main" id="{613CA8FB-CC7F-4FC5-ACCA-9F3335C22949}"/>
+                <a16:creationId xmlns:a16="http://schemas.microsoft.com/office/drawing/2014/main" id="{408F5295-5893-43A1-9150-8DCB1CD5A2EA}"/>
               </a:ext>
             </a:extLst>
           </p:cNvPr>
@@ -3306,7 +3311,7 @@
           <p:cNvPr id="43" name="qr-copy">
             <a:extLst xmlns:a="http://schemas.openxmlformats.org/drawingml/2006/main">
               <a:ext uri="{FF2B5EF4-FFF2-40B4-BE49-F238E27FC236}">
-                <a16:creationId xmlns:a16="http://schemas.microsoft.com/office/drawing/2014/main" id="{E64483E0-1616-4AAA-BA3D-8BF3C4449F18}"/>
+                <a16:creationId xmlns:a16="http://schemas.microsoft.com/office/drawing/2014/main" id="{8C845FDD-0327-4CCD-9A34-AAB1A71FE426}"/>
               </a:ext>
             </a:extLst>
           </p:cNvPr>
@@ -3318,7 +3323,7 @@
         <p:spPr>
           <a:xfrm xmlns:a="http://schemas.openxmlformats.org/drawingml/2006/main">
             <a:off x="1162050" y="27241500"/>
-            <a:ext cx="13335000" cy="1000125"/>
+            <a:ext cx="14097000" cy="1447800"/>
           </a:xfrm>
           <a:prstGeom xmlns:a="http://schemas.openxmlformats.org/drawingml/2006/main" prst="rect">
             <a:avLst/>
@@ -3388,6 +3393,33 @@
               <a:t>FPGA 工程  /  上位机  /  模型  /  仿真  /  技术文档</a:t>
             </a:r>
           </a:p>
+          <a:p xmlns:a="http://schemas.openxmlformats.org/drawingml/2006/main">
+            <a:pPr algn="l">
+              <a:lnSpc>
+                <a:spcPct val="112000"/>
+              </a:lnSpc>
+              <a:buNone/>
+              <a:defRPr sz="2100" b="0">
+                <a:solidFill>
+                  <a:srgbClr val="C1D0D7"/>
+                </a:solidFill>
+                <a:latin typeface="Microsoft YaHei"/>
+                <a:ea typeface="Microsoft YaHei"/>
+                <a:cs typeface="Microsoft YaHei"/>
+              </a:defRPr>
+            </a:pPr>
+            <a:r>
+              <a:rPr sz="2100" b="0">
+                <a:solidFill>
+                  <a:srgbClr val="C1D0D7"/>
+                </a:solidFill>
+                <a:latin typeface="Microsoft YaHei"/>
+                <a:ea typeface="Microsoft YaHei"/>
+                <a:cs typeface="Microsoft YaHei"/>
+              </a:rPr>
+              <a:t>机械设计：自制亚克力摄像头支架  /  OpenSCAD 参数化模型</a:t>
+            </a:r>
+          </a:p>
         </p:txBody>
       </p:sp>
       <p:sp>
@@ -3395,19 +3427,19 @@
           <p:cNvPr id="44" name="qr-access-note">
             <a:extLst xmlns:a="http://schemas.openxmlformats.org/drawingml/2006/main">
               <a:ext uri="{FF2B5EF4-FFF2-40B4-BE49-F238E27FC236}">
-                <a16:creationId xmlns:a16="http://schemas.microsoft.com/office/drawing/2014/main" id="{AA28371F-526A-4480-B390-17DB82C25505}"/>
-              </a:ext>
-            </a:extLst>
-          </p:cNvPr>
-          <p:cNvSpPr>
-            <a:spLocks xmlns:a="http://schemas.openxmlformats.org/drawingml/2006/main" noGrp="1"/>
-          </p:cNvSpPr>
-          <p:nvPr/>
-        </p:nvSpPr>
-        <p:spPr>
-          <a:xfrm xmlns:a="http://schemas.openxmlformats.org/drawingml/2006/main">
-            <a:off x="1162050" y="28479750"/>
-            <a:ext cx="13811250" cy="476250"/>
+                <a16:creationId xmlns:a16="http://schemas.microsoft.com/office/drawing/2014/main" id="{8E5A36EB-8A2F-41FD-9DFB-C38374F922D2}"/>
+              </a:ext>
+            </a:extLst>
+          </p:cNvPr>
+          <p:cNvSpPr>
+            <a:spLocks xmlns:a="http://schemas.openxmlformats.org/drawingml/2006/main" noGrp="1"/>
+          </p:cNvSpPr>
+          <p:nvPr/>
+        </p:nvSpPr>
+        <p:spPr>
+          <a:xfrm xmlns:a="http://schemas.openxmlformats.org/drawingml/2006/main">
+            <a:off x="1162050" y="28889325"/>
+            <a:ext cx="13811250" cy="400050"/>
           </a:xfrm>
           <a:prstGeom xmlns:a="http://schemas.openxmlformats.org/drawingml/2006/main" prst="rect">
             <a:avLst/>
@@ -3461,7 +3493,7 @@
           <p:nvPr/>
         </p:nvPicPr>
         <p:blipFill>
-          <a:blip xmlns:r="http://schemas.openxmlformats.org/officeDocument/2006/relationships" xmlns:a="http://schemas.openxmlformats.org/drawingml/2006/main" r:embed="R14777019f56a44ff"/>
+          <a:blip xmlns:r="http://schemas.openxmlformats.org/officeDocument/2006/relationships" xmlns:a="http://schemas.openxmlformats.org/drawingml/2006/main" r:embed="R865f9a939be649b6"/>
           <a:stretch xmlns:a="http://schemas.openxmlformats.org/drawingml/2006/main"/>
         </p:blipFill>
         <p:spPr>
@@ -3479,7 +3511,7 @@
           <p:cNvPr id="46" name="qr-outline">
             <a:extLst xmlns:a="http://schemas.openxmlformats.org/drawingml/2006/main">
               <a:ext uri="{FF2B5EF4-FFF2-40B4-BE49-F238E27FC236}">
-                <a16:creationId xmlns:a16="http://schemas.microsoft.com/office/drawing/2014/main" id="{96D0B8FC-3B12-4B77-95AD-F5D6A35D3E29}"/>
+                <a16:creationId xmlns:a16="http://schemas.microsoft.com/office/drawing/2014/main" id="{F3B531E5-64B5-4EC9-BF13-D5563D21DECF}"/>
               </a:ext>
             </a:extLst>
           </p:cNvPr>
@@ -3510,7 +3542,7 @@
           <p:cNvPr id="47" name="footer-project">
             <a:extLst xmlns:a="http://schemas.openxmlformats.org/drawingml/2006/main">
               <a:ext uri="{FF2B5EF4-FFF2-40B4-BE49-F238E27FC236}">
-                <a16:creationId xmlns:a16="http://schemas.microsoft.com/office/drawing/2014/main" id="{22B496E5-3A88-4D45-82CC-B09814A2A3DB}"/>
+                <a16:creationId xmlns:a16="http://schemas.microsoft.com/office/drawing/2014/main" id="{171F7207-9324-452D-A0E5-5E81BAF1B2DA}"/>
               </a:ext>
             </a:extLst>
           </p:cNvPr>
@@ -3570,7 +3602,7 @@
     </p:spTree>
     <p:extLst>
       <p:ext uri="{BB962C8B-B14F-4D97-AF65-F5344CB8AC3E}">
-        <p14:creationId xmlns:p14="http://schemas.microsoft.com/office/powerpoint/2010/main" val="1752994062"/>
+        <p14:creationId xmlns:p14="http://schemas.microsoft.com/office/powerpoint/2010/main" val="1988640056"/>
       </p:ext>
     </p:extLst>
   </p:cSld>

</xml_diff>